<commit_message>
Add Fleetana company profile (EN) and shared deck system
Profile for prospective clients: 19 slides covering who we are, vision
and mission, the problem, fleet visibility, cost visibility, route
optimisation, savings, the platform modules, Saudi fit, onboarding, team
and contact. Company facts and team are [placeholders].

Deck theme, layouts and helpers move to templates/powerpoint/deck.js so
the template and the profile share one design system. New illustrations:
per-vehicle cost breakdown and driven-vs-optimised route map.

Co-Authored-By: Claude Opus 5.5 <noreply@anthropic.com>
Claude-Session: https://claude.ai/code/session_015T4Ky8TkjrkT1kBowiQKVz
</commit_message>
<xml_diff>
--- a/fleetana-launch/brand/templates/powerpoint/Fleetana-Template-AR.pptx
+++ b/fleetana-launch/brand/templates/powerpoint/Fleetana-Template-AR.pptx
@@ -122,19 +122,19 @@
   <p:extLst>
     <p:ext uri="{521415D9-36F7-43E2-AB2F-B90AF26B5E84}">
       <p14:sectionLst xmlns:p14="http://schemas.microsoft.com/office/powerpoint/2010/main">
-        <p14:section name="مقدمة" id="{ef91f33f-40a5-9c9e-345c-bb614f395ec5}">
+        <p14:section name="مقدمة" id="{27e63217-9edf-8a7f-f7ad-745376fe4a3e}">
           <p14:sldIdLst>
             <p14:sldId id="256"/>
             <p14:sldId id="257"/>
           </p14:sldIdLst>
         </p14:section>
-        <p14:section name="المشكلة" id="{1309429b-9e57-d842-f38b-d8b9238bcc0e}">
+        <p14:section name="المشكلة" id="{b65e6a2a-158d-881a-8584-c45b6b2eeba8}">
           <p14:sldIdLst>
             <p14:sldId id="258"/>
             <p14:sldId id="259"/>
           </p14:sldIdLst>
         </p14:section>
-        <p14:section name="ما يقدمه فليتانا" id="{46f450fe-f2f0-df0f-a744-93122eef3d8d}">
+        <p14:section name="ما يقدمه فليتانا" id="{3e9096bc-50fb-2870-f120-f29595c9c547}">
           <p14:sldIdLst>
             <p14:sldId id="260"/>
             <p14:sldId id="261"/>
@@ -145,7 +145,7 @@
             <p14:sldId id="266"/>
           </p14:sldIdLst>
         </p14:section>
-        <p14:section name="العرض" id="{5421fc3d-6a0c-38c7-2311-6988fa10f195}">
+        <p14:section name="العرض" id="{a9a7dd45-3d63-9d05-d4c2-d3e0a33f57f2}">
           <p14:sldIdLst>
             <p14:sldId id="267"/>
             <p14:sldId id="268"/>

</xml_diff>